<commit_message>
Update Promotional Playbook with verified corrections and README
</commit_message>
<xml_diff>
--- a/projects/powerbi-customer-analysis/RFM_Promotional_Playbook.pptx
+++ b/projects/powerbi-customer-analysis/RFM_Promotional_Playbook.pptx
@@ -18,6 +18,7 @@
     <p:sldId id="338" r:id="rId12"/>
     <p:sldId id="339" r:id="rId13"/>
     <p:sldId id="341" r:id="rId14"/>
+    <p:sldId id="342" r:id="rId19"/>
   </p:sldIdLst>
   <p:sldSz cx="12192000" cy="6858000"/>
   <p:notesSz cx="6858000" cy="9144000"/>
@@ -3340,7 +3341,7 @@
                 </a:solidFill>
                 <a:latin typeface="Consolas"/>
               </a:rPr>
-              <a:t>01 / 13</a:t>
+              <a:t>01 / 14</a:t>
             </a:r>
           </a:p>
         </p:txBody>
@@ -3956,7 +3957,7 @@
                 </a:solidFill>
                 <a:latin typeface="Consolas"/>
               </a:rPr>
-              <a:t>10 / 13</a:t>
+              <a:t>10 / 14</a:t>
             </a:r>
           </a:p>
         </p:txBody>
@@ -4999,7 +5000,7 @@
                 </a:solidFill>
                 <a:latin typeface="Consolas"/>
               </a:rPr>
-              <a:t>11 / 13</a:t>
+              <a:t>11 / 14</a:t>
             </a:r>
           </a:p>
         </p:txBody>
@@ -5393,7 +5394,7 @@
                 </a:solidFill>
                 <a:latin typeface="Arial"/>
               </a:rPr>
-              <a:t>33 orders on an average 17% discount does not cover its cost. Either drop the offer or re-test its placement and messaging before spending more on it.</a:t>
+              <a:t>33 orders on an average 17% discount, earning a 23.5% margin after unit cost vs. 40.9% at full price. It still makes money, but about half as much per sale. Either drop the offer or re-test its placement and messaging before spending more on it.</a:t>
             </a:r>
           </a:p>
         </p:txBody>
@@ -5553,7 +5554,7 @@
                 </a:solidFill>
                 <a:latin typeface="Arial"/>
               </a:rPr>
-              <a:t>91% of quantity-discount orders stop at the shallowest tier (11-14 units, 2% off). The 5%, 10%, 15% and 20% tiers already exist but barely get used. Telling customers how close they are to the next tier costs little to try.</a:t>
+              <a:t>98% of quantity-discount orders stop at the shallowest tier (5 units, 2% off). The 5%, 10%, 15% and 20% tiers already exist but barely get used. Telling customers how close they are to the next tier costs little to try.</a:t>
             </a:r>
           </a:p>
         </p:txBody>
@@ -5713,7 +5714,7 @@
                 </a:solidFill>
                 <a:latin typeface="Arial"/>
               </a:rPr>
-              <a:t>Discount percent and unit cost are both already in the model. Join them, and "promotion effectiveness" can report profit contribution instead of just sales.</a:t>
+              <a:t>Unit cost is already on every sales line, but no measure uses it. Join it to sales, and "promotion effectiveness" can report profit contribution instead of just sales.</a:t>
             </a:r>
           </a:p>
         </p:txBody>
@@ -5862,7 +5863,7 @@
                 </a:solidFill>
                 <a:latin typeface="Consolas"/>
               </a:rPr>
-              <a:t>12 / 13</a:t>
+              <a:t>12 / 14</a:t>
             </a:r>
           </a:p>
         </p:txBody>
@@ -5936,7 +5937,7 @@
                 </a:solidFill>
                 <a:latin typeface="Arial"/>
               </a:rPr>
-              <a:t>Each of these can be verified against the dashboard's own DAX and data, and two of them change numbers a viewer would act on.</a:t>
+              <a:t>Each of these was verified against the dashboard's own DAX and data (p.14). The dashboard was submitted as-is, so they are documented here, not fixed.</a:t>
             </a:r>
           </a:p>
         </p:txBody>
@@ -6305,7 +6306,7 @@
                 </a:solidFill>
                 <a:latin typeface="Arial"/>
               </a:rPr>
-              <a:t>9 of 16 promotions predate the data</a:t>
+              <a:t>No sale falls inside any promotion's dates</a:t>
             </a:r>
           </a:p>
         </p:txBody>
@@ -6342,7 +6343,7 @@
                 </a:solidFill>
                 <a:latin typeface="Arial"/>
               </a:rPr>
-              <a:t>Their validity windows run 2010-2013, but every transaction on record is from 2020-2022. "Promotion Effectiveness by Type" really covers 2 promotion types, not the full catalog it implies.</a:t>
+              <a:t>All 16 promotions have validity windows between 2010 and mid-2014, but every transaction is from 2020-2022. 8 of the 16 have no sales at all, so "Promotion Effectiveness by Type" really covers 2 promotion types, not the full catalog it implies.</a:t>
             </a:r>
           </a:p>
         </p:txBody>
@@ -6502,7 +6503,7 @@
                 </a:solidFill>
                 <a:latin typeface="Arial"/>
               </a:rPr>
-              <a:t>unit_cost and discount_percent both exist in the model, but no measure combines them, so a deep, unprofitable discount looks identical to an efficient one.</a:t>
+              <a:t>unit_cost is on every sales line, but none of the 40 measures uses it, so a deep, low-margin discount looks identical to an efficient one. At unit cost, new-product offers earn 23.5% vs. 40.9% at full price.</a:t>
             </a:r>
           </a:p>
         </p:txBody>
@@ -6785,7 +6786,7 @@
                 </a:solidFill>
                 <a:latin typeface="Arial"/>
               </a:rPr>
-              <a:t>A mislabeled matrix, and clipped visuals</a:t>
+              <a:t>A mislabeled chart, and clipped visuals</a:t>
             </a:r>
           </a:p>
         </p:txBody>
@@ -6822,7 +6823,167 @@
                 </a:solidFill>
                 <a:latin typeface="Arial"/>
               </a:rPr>
-              <a:t>Customer Profile shows two tables titled "Occupation Distribution", but the left one is actually education level. The Gender/Age charts and segment table also scroll internally, hiding rows in a static export.</a:t>
+              <a:t>Customer Profile shows two charts titled "Occupation Distribution", but the top-right one is actually education level. The Gender/Age charts and loyalty table also scroll internally, hiding rows in a static export.</a:t>
+            </a:r>
+          </a:p>
+        </p:txBody>
+      </p:sp>
+      <p:sp>
+        <p:nvSpPr>
+          <p:cNvPr id="29" name="Rounded Rectangle 24"/>
+          <p:cNvSpPr/>
+          <p:nvPr/>
+        </p:nvSpPr>
+        <p:spPr>
+          <a:xfrm>
+            <a:off x="7955279" y="4160520"/>
+            <a:ext cx="3566160" cy="2148840"/>
+          </a:xfrm>
+          <a:prstGeom prst="roundRect">
+            <a:avLst>
+              <a:gd name="adj" fmla="val 0"/>
+            </a:avLst>
+          </a:prstGeom>
+          <a:solidFill>
+            <a:srgbClr val="EDF2F8"/>
+          </a:solidFill>
+          <a:ln w="9525">
+            <a:solidFill>
+              <a:srgbClr val="EDF2F8"/>
+            </a:solidFill>
+          </a:ln>
+          <a:effectLst/>
+        </p:spPr>
+        <p:style>
+          <a:lnRef idx="1">
+            <a:schemeClr val="accent1"/>
+          </a:lnRef>
+          <a:fillRef idx="3">
+            <a:schemeClr val="accent1"/>
+          </a:fillRef>
+          <a:effectRef idx="2">
+            <a:schemeClr val="accent1"/>
+          </a:effectRef>
+          <a:fontRef idx="minor">
+            <a:schemeClr val="lt1"/>
+          </a:fontRef>
+        </p:style>
+        <p:txBody>
+          <a:bodyPr rtlCol="0" anchor="ctr"/>
+          <a:lstStyle/>
+          <a:p>
+            <a:pPr algn="ctr"/>
+            <a:endParaRPr/>
+          </a:p>
+        </p:txBody>
+      </p:sp>
+      <p:sp>
+        <p:nvSpPr>
+          <p:cNvPr id="30" name="TextBox 25"/>
+          <p:cNvSpPr txBox="1"/>
+          <p:nvPr/>
+        </p:nvSpPr>
+        <p:spPr>
+          <a:xfrm>
+            <a:off x="8156447" y="4306824"/>
+            <a:ext cx="3163824" cy="256032"/>
+          </a:xfrm>
+          <a:prstGeom prst="rect">
+            <a:avLst/>
+          </a:prstGeom>
+          <a:noFill/>
+        </p:spPr>
+        <p:txBody>
+          <a:bodyPr wrap="square" anchor="t"/>
+          <a:lstStyle/>
+          <a:p>
+            <a:pPr algn="l">
+              <a:lnSpc>
+                <a:spcPct val="115000"/>
+              </a:lnSpc>
+            </a:pPr>
+            <a:r>
+              <a:rPr sz="950" b="1" i="0">
+                <a:solidFill>
+                  <a:srgbClr val="0E2A47"/>
+                </a:solidFill>
+                <a:latin typeface="Arial"/>
+              </a:rPr>
+              <a:t>DATA LIMITATION</a:t>
+            </a:r>
+          </a:p>
+        </p:txBody>
+      </p:sp>
+      <p:sp>
+        <p:nvSpPr>
+          <p:cNvPr id="31" name="TextBox 26"/>
+          <p:cNvSpPr txBox="1"/>
+          <p:nvPr/>
+        </p:nvSpPr>
+        <p:spPr>
+          <a:xfrm>
+            <a:off x="8156447" y="4581144"/>
+            <a:ext cx="3163824" cy="502920"/>
+          </a:xfrm>
+          <a:prstGeom prst="rect">
+            <a:avLst/>
+          </a:prstGeom>
+          <a:noFill/>
+        </p:spPr>
+        <p:txBody>
+          <a:bodyPr wrap="square" anchor="t"/>
+          <a:lstStyle/>
+          <a:p>
+            <a:pPr algn="l">
+              <a:lnSpc>
+                <a:spcPct val="112000"/>
+              </a:lnSpc>
+            </a:pPr>
+            <a:r>
+              <a:rPr sz="1250" b="1" i="0">
+                <a:solidFill>
+                  <a:srgbClr val="0E2A47"/>
+                </a:solidFill>
+                <a:latin typeface="Arial"/>
+              </a:rPr>
+              <a:t>Discount tiers don't match their own rules</a:t>
+            </a:r>
+          </a:p>
+        </p:txBody>
+      </p:sp>
+      <p:sp>
+        <p:nvSpPr>
+          <p:cNvPr id="32" name="TextBox 27"/>
+          <p:cNvSpPr txBox="1"/>
+          <p:nvPr/>
+        </p:nvSpPr>
+        <p:spPr>
+          <a:xfrm>
+            <a:off x="8156447" y="5056632"/>
+            <a:ext cx="3163824" cy="1280160"/>
+          </a:xfrm>
+          <a:prstGeom prst="rect">
+            <a:avLst/>
+          </a:prstGeom>
+          <a:noFill/>
+        </p:spPr>
+        <p:txBody>
+          <a:bodyPr wrap="square" anchor="t"/>
+          <a:lstStyle/>
+          <a:p>
+            <a:pPr algn="l">
+              <a:lnSpc>
+                <a:spcPct val="118000"/>
+              </a:lnSpc>
+            </a:pPr>
+            <a:r>
+              <a:rPr sz="930" b="0" i="0">
+                <a:solidFill>
+                  <a:srgbClr val="3D5166"/>
+                </a:solidFill>
+                <a:latin typeface="Arial"/>
+              </a:rPr>
+              <a:t>dim_promotion says the 2% tier covers 11-14 units, but every sale under it is exactly 5 units. Each tier sells at one fixed quantity (5, 15, 25, 35, 45), so its min/max columns can't be used to study tier behavior.</a:t>
             </a:r>
           </a:p>
         </p:txBody>
@@ -6971,7 +7132,7 @@
                 </a:solidFill>
                 <a:latin typeface="Consolas"/>
               </a:rPr>
-              <a:t>13 / 13</a:t>
+              <a:t>13 / 14</a:t>
             </a:r>
           </a:p>
         </p:txBody>
@@ -7045,7 +7206,7 @@
                 </a:solidFill>
                 <a:latin typeface="Arial"/>
               </a:rPr>
-              <a:t>Fix the measurement first: every recommendation in this deck depends on trusting the segment numbers behind it.</a:t>
+              <a:t>Correct the measurement first: every recommendation in this deck depends on trusting the segment numbers behind it.</a:t>
             </a:r>
           </a:p>
         </p:txBody>
@@ -7119,7 +7280,7 @@
                 </a:solidFill>
                 <a:latin typeface="Arial"/>
               </a:rPr>
-              <a:t>Fix the naming typo in the At-Risk measures. It's a one-line DAX change, and the KPI cards become accurate immediately.</a:t>
+              <a:t>Read the churn-risk cards as 4,818 customers / 4.05bn, not 3.65K / 2.69bn. In any future version, the fix is a one-line DAX change to the At-Risk measures.</a:t>
             </a:r>
           </a:p>
         </p:txBody>
@@ -7410,6 +7571,2040 @@
     <p:extLst>
       <p:ext uri="{BB962C8B-B14F-4D97-AF65-F5344CB8AC3E}">
         <p14:creationId xmlns:p14="http://schemas.microsoft.com/office/powerpoint/2010/main" val="3888493968"/>
+      </p:ext>
+    </p:extLst>
+  </p:cSld>
+  <p:clrMapOvr>
+    <a:masterClrMapping/>
+  </p:clrMapOvr>
+</p:sld>
+</file>
+
+<file path=ppt/slides/slide14.xml><?xml version="1.0" encoding="utf-8"?>
+<p:sld xmlns:a="http://schemas.openxmlformats.org/drawingml/2006/main" xmlns:r="http://schemas.openxmlformats.org/officeDocument/2006/relationships" xmlns:p="http://schemas.openxmlformats.org/presentationml/2006/main">
+  <p:cSld>
+    <p:spTree>
+      <p:nvGrpSpPr>
+        <p:cNvPr id="1" name=""/>
+        <p:cNvGrpSpPr/>
+        <p:nvPr/>
+      </p:nvGrpSpPr>
+      <p:grpSpPr>
+        <a:xfrm>
+          <a:off x="0" y="0"/>
+          <a:ext cx="0" cy="0"/>
+          <a:chOff x="0" y="0"/>
+          <a:chExt cx="0" cy="0"/>
+        </a:xfrm>
+      </p:grpSpPr>
+      <p:sp>
+        <p:nvSpPr>
+          <p:cNvPr id="2" name="Rectangle 1"/>
+          <p:cNvSpPr/>
+          <p:nvPr/>
+        </p:nvSpPr>
+        <p:spPr>
+          <a:xfrm>
+            <a:off x="0" y="0"/>
+            <a:ext cx="12191695" cy="6858000"/>
+          </a:xfrm>
+          <a:prstGeom prst="rect">
+            <a:avLst/>
+          </a:prstGeom>
+          <a:solidFill>
+            <a:srgbClr val="FFFFFF"/>
+          </a:solidFill>
+          <a:ln>
+            <a:noFill/>
+          </a:ln>
+          <a:effectLst/>
+        </p:spPr>
+        <p:style>
+          <a:lnRef idx="1">
+            <a:schemeClr val="accent1"/>
+          </a:lnRef>
+          <a:fillRef idx="3">
+            <a:schemeClr val="accent1"/>
+          </a:fillRef>
+          <a:effectRef idx="2">
+            <a:schemeClr val="accent1"/>
+          </a:effectRef>
+          <a:fontRef idx="minor">
+            <a:schemeClr val="lt1"/>
+          </a:fontRef>
+        </p:style>
+        <p:txBody>
+          <a:bodyPr rtlCol="0" anchor="ctr"/>
+          <a:lstStyle/>
+          <a:p>
+            <a:pPr algn="ctr"/>
+            <a:endParaRPr/>
+          </a:p>
+        </p:txBody>
+      </p:sp>
+      <p:sp>
+        <p:nvSpPr>
+          <p:cNvPr id="3" name="TextBox 2"/>
+          <p:cNvSpPr txBox="1"/>
+          <p:nvPr/>
+        </p:nvSpPr>
+        <p:spPr>
+          <a:xfrm>
+            <a:off x="548640" y="320040"/>
+            <a:ext cx="7315200" cy="320040"/>
+          </a:xfrm>
+          <a:prstGeom prst="rect">
+            <a:avLst/>
+          </a:prstGeom>
+          <a:noFill/>
+        </p:spPr>
+        <p:txBody>
+          <a:bodyPr wrap="square" anchor="t"/>
+          <a:lstStyle/>
+          <a:p>
+            <a:pPr algn="l">
+              <a:lnSpc>
+                <a:spcPct val="115000"/>
+              </a:lnSpc>
+            </a:pPr>
+            <a:r>
+              <a:rPr sz="1100" b="1" i="0">
+                <a:solidFill>
+                  <a:srgbClr val="2E75B6"/>
+                </a:solidFill>
+                <a:latin typeface="Arial"/>
+              </a:rPr>
+              <a:t>APPENDIX</a:t>
+            </a:r>
+          </a:p>
+        </p:txBody>
+      </p:sp>
+      <p:sp>
+        <p:nvSpPr>
+          <p:cNvPr id="4" name="TextBox 3"/>
+          <p:cNvSpPr txBox="1"/>
+          <p:nvPr/>
+        </p:nvSpPr>
+        <p:spPr>
+          <a:xfrm>
+            <a:off x="10241280" y="320040"/>
+            <a:ext cx="1371600" cy="320040"/>
+          </a:xfrm>
+          <a:prstGeom prst="rect">
+            <a:avLst/>
+          </a:prstGeom>
+          <a:noFill/>
+        </p:spPr>
+        <p:txBody>
+          <a:bodyPr wrap="square" anchor="t"/>
+          <a:lstStyle/>
+          <a:p>
+            <a:pPr algn="r">
+              <a:lnSpc>
+                <a:spcPct val="115000"/>
+              </a:lnSpc>
+            </a:pPr>
+            <a:r>
+              <a:rPr sz="1000" b="0" i="0">
+                <a:solidFill>
+                  <a:srgbClr val="3D5166"/>
+                </a:solidFill>
+                <a:latin typeface="Consolas"/>
+              </a:rPr>
+              <a:t>14 / 14</a:t>
+            </a:r>
+          </a:p>
+        </p:txBody>
+      </p:sp>
+      <p:sp>
+        <p:nvSpPr>
+          <p:cNvPr id="5" name="TextBox 4"/>
+          <p:cNvSpPr txBox="1"/>
+          <p:nvPr/>
+        </p:nvSpPr>
+        <p:spPr>
+          <a:xfrm>
+            <a:off x="548640" y="658368"/>
+            <a:ext cx="10058400" cy="502920"/>
+          </a:xfrm>
+          <a:prstGeom prst="rect">
+            <a:avLst/>
+          </a:prstGeom>
+          <a:noFill/>
+        </p:spPr>
+        <p:txBody>
+          <a:bodyPr wrap="square" anchor="t"/>
+          <a:lstStyle/>
+          <a:p>
+            <a:pPr algn="l">
+              <a:lnSpc>
+                <a:spcPct val="130000"/>
+              </a:lnSpc>
+            </a:pPr>
+            <a:r>
+              <a:rPr sz="3200" b="1" i="0">
+                <a:solidFill>
+                  <a:srgbClr val="0E2A47"/>
+                </a:solidFill>
+                <a:latin typeface="Arial"/>
+              </a:rPr>
+              <a:t>How every figure was checked</a:t>
+            </a:r>
+          </a:p>
+        </p:txBody>
+      </p:sp>
+      <p:sp>
+        <p:nvSpPr>
+          <p:cNvPr id="6" name="TextBox 5"/>
+          <p:cNvSpPr txBox="1"/>
+          <p:nvPr/>
+        </p:nvSpPr>
+        <p:spPr>
+          <a:xfrm>
+            <a:off x="548640" y="1188720"/>
+            <a:ext cx="10881360" cy="502920"/>
+          </a:xfrm>
+          <a:prstGeom prst="rect">
+            <a:avLst/>
+          </a:prstGeom>
+          <a:noFill/>
+        </p:spPr>
+        <p:txBody>
+          <a:bodyPr wrap="square" anchor="t"/>
+          <a:lstStyle/>
+          <a:p>
+            <a:pPr algn="l">
+              <a:lnSpc>
+                <a:spcPct val="130000"/>
+              </a:lnSpc>
+            </a:pPr>
+            <a:r>
+              <a:rPr sz="1150" b="0" i="0">
+                <a:solidFill>
+                  <a:srgbClr val="3D5166"/>
+                </a:solidFill>
+                <a:latin typeface="Arial"/>
+              </a:rPr>
+              <a:t>Each number was recomputed from the .pbix's own DAX, relationships and tables. Rows marked Revised differ from the first version of this deck.</a:t>
+            </a:r>
+          </a:p>
+        </p:txBody>
+      </p:sp>
+      <p:graphicFrame>
+        <p:nvGraphicFramePr>
+          <p:cNvPr id="7" name="Verification Table"/>
+          <p:cNvGraphicFramePr>
+            <a:graphicFrameLocks noGrp="1"/>
+          </p:cNvGraphicFramePr>
+          <p:nvPr/>
+        </p:nvGraphicFramePr>
+        <p:xfrm>
+          <a:off x="548640" y="1783080"/>
+          <a:ext cx="10972800" cy="4169664"/>
+        </p:xfrm>
+        <a:graphic>
+          <a:graphicData uri="http://schemas.openxmlformats.org/drawingml/2006/table">
+            <a:tbl>
+              <a:tblPr firstRow="1" bandRow="1"/>
+              <a:tblGrid>
+                <a:gridCol w="3474720"/>
+                <a:gridCol w="2286000"/>
+                <a:gridCol w="3017520"/>
+                <a:gridCol w="2194560"/>
+              </a:tblGrid>
+              <a:tr h="347472">
+                <a:tc>
+                  <a:txBody>
+                    <a:bodyPr/>
+                    <a:lstStyle/>
+                    <a:p>
+                      <a:r>
+                        <a:rPr lang="en-US" sz="1000" b="1" dirty="0">
+                          <a:solidFill>
+                            <a:srgbClr val="FFFFFF"/>
+                          </a:solidFill>
+                          <a:latin typeface="Arial"/>
+                        </a:rPr>
+                        <a:t>Figure</a:t>
+                      </a:r>
+                    </a:p>
+                  </a:txBody>
+                  <a:tcPr marL="91440" marR="91440" marT="45720" marB="45720" anchor="ctr">
+                    <a:lnL w="0">
+                      <a:noFill/>
+                    </a:lnL>
+                    <a:lnR w="0">
+                      <a:noFill/>
+                    </a:lnR>
+                    <a:lnT w="0">
+                      <a:noFill/>
+                    </a:lnT>
+                    <a:lnB w="6350">
+                      <a:solidFill>
+                        <a:srgbClr val="D5DEE8"/>
+                      </a:solidFill>
+                    </a:lnB>
+                    <a:solidFill>
+                      <a:srgbClr val="0E2A47"/>
+                    </a:solidFill>
+                  </a:tcPr>
+                </a:tc>
+                <a:tc>
+                  <a:txBody>
+                    <a:bodyPr/>
+                    <a:lstStyle/>
+                    <a:p>
+                      <a:r>
+                        <a:rPr lang="en-US" sz="1000" b="1" dirty="0">
+                          <a:solidFill>
+                            <a:srgbClr val="FFFFFF"/>
+                          </a:solidFill>
+                          <a:latin typeface="Arial"/>
+                        </a:rPr>
+                        <a:t>Dashboard / deck said</a:t>
+                      </a:r>
+                    </a:p>
+                  </a:txBody>
+                  <a:tcPr marL="91440" marR="91440" marT="45720" marB="45720" anchor="ctr">
+                    <a:lnL w="0">
+                      <a:noFill/>
+                    </a:lnL>
+                    <a:lnR w="0">
+                      <a:noFill/>
+                    </a:lnR>
+                    <a:lnT w="0">
+                      <a:noFill/>
+                    </a:lnT>
+                    <a:lnB w="6350">
+                      <a:solidFill>
+                        <a:srgbClr val="D5DEE8"/>
+                      </a:solidFill>
+                    </a:lnB>
+                    <a:solidFill>
+                      <a:srgbClr val="0E2A47"/>
+                    </a:solidFill>
+                  </a:tcPr>
+                </a:tc>
+                <a:tc>
+                  <a:txBody>
+                    <a:bodyPr/>
+                    <a:lstStyle/>
+                    <a:p>
+                      <a:r>
+                        <a:rPr lang="en-US" sz="1000" b="1" dirty="0">
+                          <a:solidFill>
+                            <a:srgbClr val="FFFFFF"/>
+                          </a:solidFill>
+                          <a:latin typeface="Arial"/>
+                        </a:rPr>
+                        <a:t>Model shows</a:t>
+                      </a:r>
+                    </a:p>
+                  </a:txBody>
+                  <a:tcPr marL="91440" marR="91440" marT="45720" marB="45720" anchor="ctr">
+                    <a:lnL w="0">
+                      <a:noFill/>
+                    </a:lnL>
+                    <a:lnR w="0">
+                      <a:noFill/>
+                    </a:lnR>
+                    <a:lnT w="0">
+                      <a:noFill/>
+                    </a:lnT>
+                    <a:lnB w="6350">
+                      <a:solidFill>
+                        <a:srgbClr val="D5DEE8"/>
+                      </a:solidFill>
+                    </a:lnB>
+                    <a:solidFill>
+                      <a:srgbClr val="0E2A47"/>
+                    </a:solidFill>
+                  </a:tcPr>
+                </a:tc>
+                <a:tc>
+                  <a:txBody>
+                    <a:bodyPr/>
+                    <a:lstStyle/>
+                    <a:p>
+                      <a:r>
+                        <a:rPr lang="en-US" sz="1000" b="1" dirty="0">
+                          <a:solidFill>
+                            <a:srgbClr val="FFFFFF"/>
+                          </a:solidFill>
+                          <a:latin typeface="Arial"/>
+                        </a:rPr>
+                        <a:t>Status</a:t>
+                      </a:r>
+                    </a:p>
+                  </a:txBody>
+                  <a:tcPr marL="91440" marR="91440" marT="45720" marB="45720" anchor="ctr">
+                    <a:lnL w="0">
+                      <a:noFill/>
+                    </a:lnL>
+                    <a:lnR w="0">
+                      <a:noFill/>
+                    </a:lnR>
+                    <a:lnT w="0">
+                      <a:noFill/>
+                    </a:lnT>
+                    <a:lnB w="6350">
+                      <a:solidFill>
+                        <a:srgbClr val="D5DEE8"/>
+                      </a:solidFill>
+                    </a:lnB>
+                    <a:solidFill>
+                      <a:srgbClr val="0E2A47"/>
+                    </a:solidFill>
+                  </a:tcPr>
+                </a:tc>
+              </a:tr>
+              <a:tr h="347472">
+                <a:tc>
+                  <a:txBody>
+                    <a:bodyPr/>
+                    <a:lstStyle/>
+                    <a:p>
+                      <a:r>
+                        <a:rPr lang="en-US" sz="1000" b="0" dirty="0">
+                          <a:solidFill>
+                            <a:srgbClr val="0E2A47"/>
+                          </a:solidFill>
+                          <a:latin typeface="Arial"/>
+                        </a:rPr>
+                        <a:t>Customers / revenue at churn risk</a:t>
+                      </a:r>
+                    </a:p>
+                  </a:txBody>
+                  <a:tcPr marL="91440" marR="91440" marT="45720" marB="45720" anchor="ctr">
+                    <a:lnL w="0">
+                      <a:noFill/>
+                    </a:lnL>
+                    <a:lnR w="0">
+                      <a:noFill/>
+                    </a:lnR>
+                    <a:lnT w="0">
+                      <a:noFill/>
+                    </a:lnT>
+                    <a:lnB w="6350">
+                      <a:solidFill>
+                        <a:srgbClr val="D5DEE8"/>
+                      </a:solidFill>
+                    </a:lnB>
+                    <a:solidFill>
+                      <a:srgbClr val="FFFFFF"/>
+                    </a:solidFill>
+                  </a:tcPr>
+                </a:tc>
+                <a:tc>
+                  <a:txBody>
+                    <a:bodyPr/>
+                    <a:lstStyle/>
+                    <a:p>
+                      <a:r>
+                        <a:rPr lang="en-US" sz="1000" b="0" dirty="0">
+                          <a:solidFill>
+                            <a:srgbClr val="3D5166"/>
+                          </a:solidFill>
+                          <a:latin typeface="Arial"/>
+                        </a:rPr>
+                        <a:t>3.65K / 2.69bn</a:t>
+                      </a:r>
+                    </a:p>
+                  </a:txBody>
+                  <a:tcPr marL="91440" marR="91440" marT="45720" marB="45720" anchor="ctr">
+                    <a:lnL w="0">
+                      <a:noFill/>
+                    </a:lnL>
+                    <a:lnR w="0">
+                      <a:noFill/>
+                    </a:lnR>
+                    <a:lnT w="0">
+                      <a:noFill/>
+                    </a:lnT>
+                    <a:lnB w="6350">
+                      <a:solidFill>
+                        <a:srgbClr val="D5DEE8"/>
+                      </a:solidFill>
+                    </a:lnB>
+                    <a:solidFill>
+                      <a:srgbClr val="FFFFFF"/>
+                    </a:solidFill>
+                  </a:tcPr>
+                </a:tc>
+                <a:tc>
+                  <a:txBody>
+                    <a:bodyPr/>
+                    <a:lstStyle/>
+                    <a:p>
+                      <a:r>
+                        <a:rPr lang="en-US" sz="1000" b="0" dirty="0">
+                          <a:solidFill>
+                            <a:srgbClr val="3D5166"/>
+                          </a:solidFill>
+                          <a:latin typeface="Arial"/>
+                        </a:rPr>
+                        <a:t>4,818 / 4.05bn</a:t>
+                      </a:r>
+                    </a:p>
+                  </a:txBody>
+                  <a:tcPr marL="91440" marR="91440" marT="45720" marB="45720" anchor="ctr">
+                    <a:lnL w="0">
+                      <a:noFill/>
+                    </a:lnL>
+                    <a:lnR w="0">
+                      <a:noFill/>
+                    </a:lnR>
+                    <a:lnT w="0">
+                      <a:noFill/>
+                    </a:lnT>
+                    <a:lnB w="6350">
+                      <a:solidFill>
+                        <a:srgbClr val="D5DEE8"/>
+                      </a:solidFill>
+                    </a:lnB>
+                    <a:solidFill>
+                      <a:srgbClr val="FFFFFF"/>
+                    </a:solidFill>
+                  </a:tcPr>
+                </a:tc>
+                <a:tc>
+                  <a:txBody>
+                    <a:bodyPr/>
+                    <a:lstStyle/>
+                    <a:p>
+                      <a:r>
+                        <a:rPr lang="en-US" sz="1000" b="1" dirty="0">
+                          <a:solidFill>
+                            <a:srgbClr val="2E75B6"/>
+                          </a:solidFill>
+                          <a:latin typeface="Arial"/>
+                        </a:rPr>
+                        <a:t>Dashboard bug</a:t>
+                      </a:r>
+                    </a:p>
+                  </a:txBody>
+                  <a:tcPr marL="91440" marR="91440" marT="45720" marB="45720" anchor="ctr">
+                    <a:lnL w="0">
+                      <a:noFill/>
+                    </a:lnL>
+                    <a:lnR w="0">
+                      <a:noFill/>
+                    </a:lnR>
+                    <a:lnT w="0">
+                      <a:noFill/>
+                    </a:lnT>
+                    <a:lnB w="6350">
+                      <a:solidFill>
+                        <a:srgbClr val="D5DEE8"/>
+                      </a:solidFill>
+                    </a:lnB>
+                    <a:solidFill>
+                      <a:srgbClr val="FFFFFF"/>
+                    </a:solidFill>
+                  </a:tcPr>
+                </a:tc>
+              </a:tr>
+              <a:tr h="347472">
+                <a:tc>
+                  <a:txBody>
+                    <a:bodyPr/>
+                    <a:lstStyle/>
+                    <a:p>
+                      <a:r>
+                        <a:rPr lang="en-US" sz="1000" b="0" dirty="0">
+                          <a:solidFill>
+                            <a:srgbClr val="0E2A47"/>
+                          </a:solidFill>
+                          <a:latin typeface="Arial"/>
+                        </a:rPr>
+                        <a:t>Discount Dependency Index</a:t>
+                      </a:r>
+                    </a:p>
+                  </a:txBody>
+                  <a:tcPr marL="91440" marR="91440" marT="45720" marB="45720" anchor="ctr">
+                    <a:lnL w="0">
+                      <a:noFill/>
+                    </a:lnL>
+                    <a:lnR w="0">
+                      <a:noFill/>
+                    </a:lnR>
+                    <a:lnT w="0">
+                      <a:noFill/>
+                    </a:lnT>
+                    <a:lnB w="6350">
+                      <a:solidFill>
+                        <a:srgbClr val="D5DEE8"/>
+                      </a:solidFill>
+                    </a:lnB>
+                    <a:solidFill>
+                      <a:srgbClr val="EDF2F8"/>
+                    </a:solidFill>
+                  </a:tcPr>
+                </a:tc>
+                <a:tc>
+                  <a:txBody>
+                    <a:bodyPr/>
+                    <a:lstStyle/>
+                    <a:p>
+                      <a:r>
+                        <a:rPr lang="en-US" sz="1000" b="0" dirty="0">
+                          <a:solidFill>
+                            <a:srgbClr val="3D5166"/>
+                          </a:solidFill>
+                          <a:latin typeface="Arial"/>
+                        </a:rPr>
+                        <a:t>2.05%</a:t>
+                      </a:r>
+                    </a:p>
+                  </a:txBody>
+                  <a:tcPr marL="91440" marR="91440" marT="45720" marB="45720" anchor="ctr">
+                    <a:lnL w="0">
+                      <a:noFill/>
+                    </a:lnL>
+                    <a:lnR w="0">
+                      <a:noFill/>
+                    </a:lnR>
+                    <a:lnT w="0">
+                      <a:noFill/>
+                    </a:lnT>
+                    <a:lnB w="6350">
+                      <a:solidFill>
+                        <a:srgbClr val="D5DEE8"/>
+                      </a:solidFill>
+                    </a:lnB>
+                    <a:solidFill>
+                      <a:srgbClr val="EDF2F8"/>
+                    </a:solidFill>
+                  </a:tcPr>
+                </a:tc>
+                <a:tc>
+                  <a:txBody>
+                    <a:bodyPr/>
+                    <a:lstStyle/>
+                    <a:p>
+                      <a:r>
+                        <a:rPr lang="en-US" sz="1000" b="0" dirty="0">
+                          <a:solidFill>
+                            <a:srgbClr val="3D5166"/>
+                          </a:solidFill>
+                          <a:latin typeface="Arial"/>
+                        </a:rPr>
+                        <a:t>2.05%</a:t>
+                      </a:r>
+                    </a:p>
+                  </a:txBody>
+                  <a:tcPr marL="91440" marR="91440" marT="45720" marB="45720" anchor="ctr">
+                    <a:lnL w="0">
+                      <a:noFill/>
+                    </a:lnL>
+                    <a:lnR w="0">
+                      <a:noFill/>
+                    </a:lnR>
+                    <a:lnT w="0">
+                      <a:noFill/>
+                    </a:lnT>
+                    <a:lnB w="6350">
+                      <a:solidFill>
+                        <a:srgbClr val="D5DEE8"/>
+                      </a:solidFill>
+                    </a:lnB>
+                    <a:solidFill>
+                      <a:srgbClr val="EDF2F8"/>
+                    </a:solidFill>
+                  </a:tcPr>
+                </a:tc>
+                <a:tc>
+                  <a:txBody>
+                    <a:bodyPr/>
+                    <a:lstStyle/>
+                    <a:p>
+                      <a:r>
+                        <a:rPr lang="en-US" sz="1000" b="0" dirty="0">
+                          <a:solidFill>
+                            <a:srgbClr val="3D5166"/>
+                          </a:solidFill>
+                          <a:latin typeface="Arial"/>
+                        </a:rPr>
+                        <a:t>Matches</a:t>
+                      </a:r>
+                    </a:p>
+                  </a:txBody>
+                  <a:tcPr marL="91440" marR="91440" marT="45720" marB="45720" anchor="ctr">
+                    <a:lnL w="0">
+                      <a:noFill/>
+                    </a:lnL>
+                    <a:lnR w="0">
+                      <a:noFill/>
+                    </a:lnR>
+                    <a:lnT w="0">
+                      <a:noFill/>
+                    </a:lnT>
+                    <a:lnB w="6350">
+                      <a:solidFill>
+                        <a:srgbClr val="D5DEE8"/>
+                      </a:solidFill>
+                    </a:lnB>
+                    <a:solidFill>
+                      <a:srgbClr val="EDF2F8"/>
+                    </a:solidFill>
+                  </a:tcPr>
+                </a:tc>
+              </a:tr>
+              <a:tr h="347472">
+                <a:tc>
+                  <a:txBody>
+                    <a:bodyPr/>
+                    <a:lstStyle/>
+                    <a:p>
+                      <a:r>
+                        <a:rPr lang="en-US" sz="1000" b="0" dirty="0">
+                          <a:solidFill>
+                            <a:srgbClr val="0E2A47"/>
+                          </a:solidFill>
+                          <a:latin typeface="Arial"/>
+                        </a:rPr>
+                        <a:t>Average recency</a:t>
+                      </a:r>
+                    </a:p>
+                  </a:txBody>
+                  <a:tcPr marL="91440" marR="91440" marT="45720" marB="45720" anchor="ctr">
+                    <a:lnL w="0">
+                      <a:noFill/>
+                    </a:lnL>
+                    <a:lnR w="0">
+                      <a:noFill/>
+                    </a:lnR>
+                    <a:lnT w="0">
+                      <a:noFill/>
+                    </a:lnT>
+                    <a:lnB w="6350">
+                      <a:solidFill>
+                        <a:srgbClr val="D5DEE8"/>
+                      </a:solidFill>
+                    </a:lnB>
+                    <a:solidFill>
+                      <a:srgbClr val="FFFFFF"/>
+                    </a:solidFill>
+                  </a:tcPr>
+                </a:tc>
+                <a:tc>
+                  <a:txBody>
+                    <a:bodyPr/>
+                    <a:lstStyle/>
+                    <a:p>
+                      <a:r>
+                        <a:rPr lang="en-US" sz="1000" b="0" dirty="0">
+                          <a:solidFill>
+                            <a:srgbClr val="3D5166"/>
+                          </a:solidFill>
+                          <a:latin typeface="Arial"/>
+                        </a:rPr>
+                        <a:t>100 days</a:t>
+                      </a:r>
+                    </a:p>
+                  </a:txBody>
+                  <a:tcPr marL="91440" marR="91440" marT="45720" marB="45720" anchor="ctr">
+                    <a:lnL w="0">
+                      <a:noFill/>
+                    </a:lnL>
+                    <a:lnR w="0">
+                      <a:noFill/>
+                    </a:lnR>
+                    <a:lnT w="0">
+                      <a:noFill/>
+                    </a:lnT>
+                    <a:lnB w="6350">
+                      <a:solidFill>
+                        <a:srgbClr val="D5DEE8"/>
+                      </a:solidFill>
+                    </a:lnB>
+                    <a:solidFill>
+                      <a:srgbClr val="FFFFFF"/>
+                    </a:solidFill>
+                  </a:tcPr>
+                </a:tc>
+                <a:tc>
+                  <a:txBody>
+                    <a:bodyPr/>
+                    <a:lstStyle/>
+                    <a:p>
+                      <a:r>
+                        <a:rPr lang="en-US" sz="1000" b="0" dirty="0">
+                          <a:solidFill>
+                            <a:srgbClr val="3D5166"/>
+                          </a:solidFill>
+                          <a:latin typeface="Arial"/>
+                        </a:rPr>
+                        <a:t>100.4 days (15 to 250 by segment)</a:t>
+                      </a:r>
+                    </a:p>
+                  </a:txBody>
+                  <a:tcPr marL="91440" marR="91440" marT="45720" marB="45720" anchor="ctr">
+                    <a:lnL w="0">
+                      <a:noFill/>
+                    </a:lnL>
+                    <a:lnR w="0">
+                      <a:noFill/>
+                    </a:lnR>
+                    <a:lnT w="0">
+                      <a:noFill/>
+                    </a:lnT>
+                    <a:lnB w="6350">
+                      <a:solidFill>
+                        <a:srgbClr val="D5DEE8"/>
+                      </a:solidFill>
+                    </a:lnB>
+                    <a:solidFill>
+                      <a:srgbClr val="FFFFFF"/>
+                    </a:solidFill>
+                  </a:tcPr>
+                </a:tc>
+                <a:tc>
+                  <a:txBody>
+                    <a:bodyPr/>
+                    <a:lstStyle/>
+                    <a:p>
+                      <a:r>
+                        <a:rPr lang="en-US" sz="1000" b="0" dirty="0">
+                          <a:solidFill>
+                            <a:srgbClr val="3D5166"/>
+                          </a:solidFill>
+                          <a:latin typeface="Arial"/>
+                        </a:rPr>
+                        <a:t>Matches</a:t>
+                      </a:r>
+                    </a:p>
+                  </a:txBody>
+                  <a:tcPr marL="91440" marR="91440" marT="45720" marB="45720" anchor="ctr">
+                    <a:lnL w="0">
+                      <a:noFill/>
+                    </a:lnL>
+                    <a:lnR w="0">
+                      <a:noFill/>
+                    </a:lnR>
+                    <a:lnT w="0">
+                      <a:noFill/>
+                    </a:lnT>
+                    <a:lnB w="6350">
+                      <a:solidFill>
+                        <a:srgbClr val="D5DEE8"/>
+                      </a:solidFill>
+                    </a:lnB>
+                    <a:solidFill>
+                      <a:srgbClr val="FFFFFF"/>
+                    </a:solidFill>
+                  </a:tcPr>
+                </a:tc>
+              </a:tr>
+              <a:tr h="347472">
+                <a:tc>
+                  <a:txBody>
+                    <a:bodyPr/>
+                    <a:lstStyle/>
+                    <a:p>
+                      <a:r>
+                        <a:rPr lang="en-US" sz="1000" b="0" dirty="0">
+                          <a:solidFill>
+                            <a:srgbClr val="0E2A47"/>
+                          </a:solidFill>
+                          <a:latin typeface="Arial"/>
+                        </a:rPr>
+                        <a:t>Promo share of revenue 2020 / 21 / 22</a:t>
+                      </a:r>
+                    </a:p>
+                  </a:txBody>
+                  <a:tcPr marL="91440" marR="91440" marT="45720" marB="45720" anchor="ctr">
+                    <a:lnL w="0">
+                      <a:noFill/>
+                    </a:lnL>
+                    <a:lnR w="0">
+                      <a:noFill/>
+                    </a:lnR>
+                    <a:lnT w="0">
+                      <a:noFill/>
+                    </a:lnT>
+                    <a:lnB w="6350">
+                      <a:solidFill>
+                        <a:srgbClr val="D5DEE8"/>
+                      </a:solidFill>
+                    </a:lnB>
+                    <a:solidFill>
+                      <a:srgbClr val="EDF2F8"/>
+                    </a:solidFill>
+                  </a:tcPr>
+                </a:tc>
+                <a:tc>
+                  <a:txBody>
+                    <a:bodyPr/>
+                    <a:lstStyle/>
+                    <a:p>
+                      <a:r>
+                        <a:rPr lang="en-US" sz="1000" b="0" dirty="0">
+                          <a:solidFill>
+                            <a:srgbClr val="3D5166"/>
+                          </a:solidFill>
+                          <a:latin typeface="Arial"/>
+                        </a:rPr>
+                        <a:t>1.1% / 54.3% / 16.1%</a:t>
+                      </a:r>
+                    </a:p>
+                  </a:txBody>
+                  <a:tcPr marL="91440" marR="91440" marT="45720" marB="45720" anchor="ctr">
+                    <a:lnL w="0">
+                      <a:noFill/>
+                    </a:lnL>
+                    <a:lnR w="0">
+                      <a:noFill/>
+                    </a:lnR>
+                    <a:lnT w="0">
+                      <a:noFill/>
+                    </a:lnT>
+                    <a:lnB w="6350">
+                      <a:solidFill>
+                        <a:srgbClr val="D5DEE8"/>
+                      </a:solidFill>
+                    </a:lnB>
+                    <a:solidFill>
+                      <a:srgbClr val="EDF2F8"/>
+                    </a:solidFill>
+                  </a:tcPr>
+                </a:tc>
+                <a:tc>
+                  <a:txBody>
+                    <a:bodyPr/>
+                    <a:lstStyle/>
+                    <a:p>
+                      <a:r>
+                        <a:rPr lang="en-US" sz="1000" b="0" dirty="0">
+                          <a:solidFill>
+                            <a:srgbClr val="3D5166"/>
+                          </a:solidFill>
+                          <a:latin typeface="Arial"/>
+                        </a:rPr>
+                        <a:t>1.1% / 54.3% / 16.1%</a:t>
+                      </a:r>
+                    </a:p>
+                  </a:txBody>
+                  <a:tcPr marL="91440" marR="91440" marT="45720" marB="45720" anchor="ctr">
+                    <a:lnL w="0">
+                      <a:noFill/>
+                    </a:lnL>
+                    <a:lnR w="0">
+                      <a:noFill/>
+                    </a:lnR>
+                    <a:lnT w="0">
+                      <a:noFill/>
+                    </a:lnT>
+                    <a:lnB w="6350">
+                      <a:solidFill>
+                        <a:srgbClr val="D5DEE8"/>
+                      </a:solidFill>
+                    </a:lnB>
+                    <a:solidFill>
+                      <a:srgbClr val="EDF2F8"/>
+                    </a:solidFill>
+                  </a:tcPr>
+                </a:tc>
+                <a:tc>
+                  <a:txBody>
+                    <a:bodyPr/>
+                    <a:lstStyle/>
+                    <a:p>
+                      <a:r>
+                        <a:rPr lang="en-US" sz="1000" b="0" dirty="0">
+                          <a:solidFill>
+                            <a:srgbClr val="3D5166"/>
+                          </a:solidFill>
+                          <a:latin typeface="Arial"/>
+                        </a:rPr>
+                        <a:t>Matches</a:t>
+                      </a:r>
+                    </a:p>
+                  </a:txBody>
+                  <a:tcPr marL="91440" marR="91440" marT="45720" marB="45720" anchor="ctr">
+                    <a:lnL w="0">
+                      <a:noFill/>
+                    </a:lnL>
+                    <a:lnR w="0">
+                      <a:noFill/>
+                    </a:lnR>
+                    <a:lnT w="0">
+                      <a:noFill/>
+                    </a:lnT>
+                    <a:lnB w="6350">
+                      <a:solidFill>
+                        <a:srgbClr val="D5DEE8"/>
+                      </a:solidFill>
+                    </a:lnB>
+                    <a:solidFill>
+                      <a:srgbClr val="EDF2F8"/>
+                    </a:solidFill>
+                  </a:tcPr>
+                </a:tc>
+              </a:tr>
+              <a:tr h="347472">
+                <a:tc>
+                  <a:txBody>
+                    <a:bodyPr/>
+                    <a:lstStyle/>
+                    <a:p>
+                      <a:r>
+                        <a:rPr lang="en-US" sz="1000" b="0" dirty="0">
+                          <a:solidFill>
+                            <a:srgbClr val="0E2A47"/>
+                          </a:solidFill>
+                          <a:latin typeface="Arial"/>
+                        </a:rPr>
+                        <a:t>Promo vs. full-price order value</a:t>
+                      </a:r>
+                    </a:p>
+                  </a:txBody>
+                  <a:tcPr marL="91440" marR="91440" marT="45720" marB="45720" anchor="ctr">
+                    <a:lnL w="0">
+                      <a:noFill/>
+                    </a:lnL>
+                    <a:lnR w="0">
+                      <a:noFill/>
+                    </a:lnR>
+                    <a:lnT w="0">
+                      <a:noFill/>
+                    </a:lnT>
+                    <a:lnB w="6350">
+                      <a:solidFill>
+                        <a:srgbClr val="D5DEE8"/>
+                      </a:solidFill>
+                    </a:lnB>
+                    <a:solidFill>
+                      <a:srgbClr val="FFFFFF"/>
+                    </a:solidFill>
+                  </a:tcPr>
+                </a:tc>
+                <a:tc>
+                  <a:txBody>
+                    <a:bodyPr/>
+                    <a:lstStyle/>
+                    <a:p>
+                      <a:r>
+                        <a:rPr lang="en-US" sz="1000" b="0" dirty="0">
+                          <a:solidFill>
+                            <a:srgbClr val="3D5166"/>
+                          </a:solidFill>
+                          <a:latin typeface="Arial"/>
+                        </a:rPr>
+                        <a:t>4.7x</a:t>
+                      </a:r>
+                    </a:p>
+                  </a:txBody>
+                  <a:tcPr marL="91440" marR="91440" marT="45720" marB="45720" anchor="ctr">
+                    <a:lnL w="0">
+                      <a:noFill/>
+                    </a:lnL>
+                    <a:lnR w="0">
+                      <a:noFill/>
+                    </a:lnR>
+                    <a:lnT w="0">
+                      <a:noFill/>
+                    </a:lnT>
+                    <a:lnB w="6350">
+                      <a:solidFill>
+                        <a:srgbClr val="D5DEE8"/>
+                      </a:solidFill>
+                    </a:lnB>
+                    <a:solidFill>
+                      <a:srgbClr val="FFFFFF"/>
+                    </a:solidFill>
+                  </a:tcPr>
+                </a:tc>
+                <a:tc>
+                  <a:txBody>
+                    <a:bodyPr/>
+                    <a:lstStyle/>
+                    <a:p>
+                      <a:r>
+                        <a:rPr lang="en-US" sz="1000" b="0" dirty="0">
+                          <a:solidFill>
+                            <a:srgbClr val="3D5166"/>
+                          </a:solidFill>
+                          <a:latin typeface="Arial"/>
+                        </a:rPr>
+                        <a:t>4.67x</a:t>
+                      </a:r>
+                    </a:p>
+                  </a:txBody>
+                  <a:tcPr marL="91440" marR="91440" marT="45720" marB="45720" anchor="ctr">
+                    <a:lnL w="0">
+                      <a:noFill/>
+                    </a:lnL>
+                    <a:lnR w="0">
+                      <a:noFill/>
+                    </a:lnR>
+                    <a:lnT w="0">
+                      <a:noFill/>
+                    </a:lnT>
+                    <a:lnB w="6350">
+                      <a:solidFill>
+                        <a:srgbClr val="D5DEE8"/>
+                      </a:solidFill>
+                    </a:lnB>
+                    <a:solidFill>
+                      <a:srgbClr val="FFFFFF"/>
+                    </a:solidFill>
+                  </a:tcPr>
+                </a:tc>
+                <a:tc>
+                  <a:txBody>
+                    <a:bodyPr/>
+                    <a:lstStyle/>
+                    <a:p>
+                      <a:r>
+                        <a:rPr lang="en-US" sz="1000" b="0" dirty="0">
+                          <a:solidFill>
+                            <a:srgbClr val="3D5166"/>
+                          </a:solidFill>
+                          <a:latin typeface="Arial"/>
+                        </a:rPr>
+                        <a:t>Matches</a:t>
+                      </a:r>
+                    </a:p>
+                  </a:txBody>
+                  <a:tcPr marL="91440" marR="91440" marT="45720" marB="45720" anchor="ctr">
+                    <a:lnL w="0">
+                      <a:noFill/>
+                    </a:lnL>
+                    <a:lnR w="0">
+                      <a:noFill/>
+                    </a:lnR>
+                    <a:lnT w="0">
+                      <a:noFill/>
+                    </a:lnT>
+                    <a:lnB w="6350">
+                      <a:solidFill>
+                        <a:srgbClr val="D5DEE8"/>
+                      </a:solidFill>
+                    </a:lnB>
+                    <a:solidFill>
+                      <a:srgbClr val="FFFFFF"/>
+                    </a:solidFill>
+                  </a:tcPr>
+                </a:tc>
+              </a:tr>
+              <a:tr h="347472">
+                <a:tc>
+                  <a:txBody>
+                    <a:bodyPr/>
+                    <a:lstStyle/>
+                    <a:p>
+                      <a:r>
+                        <a:rPr lang="en-US" sz="1000" b="0" dirty="0">
+                          <a:solidFill>
+                            <a:srgbClr val="0E2A47"/>
+                          </a:solidFill>
+                          <a:latin typeface="Arial"/>
+                        </a:rPr>
+                        <a:t>Promo dependency by segment (p.8)</a:t>
+                      </a:r>
+                    </a:p>
+                  </a:txBody>
+                  <a:tcPr marL="91440" marR="91440" marT="45720" marB="45720" anchor="ctr">
+                    <a:lnL w="0">
+                      <a:noFill/>
+                    </a:lnL>
+                    <a:lnR w="0">
+                      <a:noFill/>
+                    </a:lnR>
+                    <a:lnT w="0">
+                      <a:noFill/>
+                    </a:lnT>
+                    <a:lnB w="6350">
+                      <a:solidFill>
+                        <a:srgbClr val="D5DEE8"/>
+                      </a:solidFill>
+                    </a:lnB>
+                    <a:solidFill>
+                      <a:srgbClr val="EDF2F8"/>
+                    </a:solidFill>
+                  </a:tcPr>
+                </a:tc>
+                <a:tc>
+                  <a:txBody>
+                    <a:bodyPr/>
+                    <a:lstStyle/>
+                    <a:p>
+                      <a:r>
+                        <a:rPr lang="en-US" sz="1000" b="0" dirty="0">
+                          <a:solidFill>
+                            <a:srgbClr val="3D5166"/>
+                          </a:solidFill>
+                          <a:latin typeface="Arial"/>
+                        </a:rPr>
+                        <a:t>1.1% to 3.1%</a:t>
+                      </a:r>
+                    </a:p>
+                  </a:txBody>
+                  <a:tcPr marL="91440" marR="91440" marT="45720" marB="45720" anchor="ctr">
+                    <a:lnL w="0">
+                      <a:noFill/>
+                    </a:lnL>
+                    <a:lnR w="0">
+                      <a:noFill/>
+                    </a:lnR>
+                    <a:lnT w="0">
+                      <a:noFill/>
+                    </a:lnT>
+                    <a:lnB w="6350">
+                      <a:solidFill>
+                        <a:srgbClr val="D5DEE8"/>
+                      </a:solidFill>
+                    </a:lnB>
+                    <a:solidFill>
+                      <a:srgbClr val="EDF2F8"/>
+                    </a:solidFill>
+                  </a:tcPr>
+                </a:tc>
+                <a:tc>
+                  <a:txBody>
+                    <a:bodyPr/>
+                    <a:lstStyle/>
+                    <a:p>
+                      <a:r>
+                        <a:rPr lang="en-US" sz="1000" b="0" dirty="0">
+                          <a:solidFill>
+                            <a:srgbClr val="3D5166"/>
+                          </a:solidFill>
+                          <a:latin typeface="Arial"/>
+                        </a:rPr>
+                        <a:t>1.1% to 3.1%</a:t>
+                      </a:r>
+                    </a:p>
+                  </a:txBody>
+                  <a:tcPr marL="91440" marR="91440" marT="45720" marB="45720" anchor="ctr">
+                    <a:lnL w="0">
+                      <a:noFill/>
+                    </a:lnL>
+                    <a:lnR w="0">
+                      <a:noFill/>
+                    </a:lnR>
+                    <a:lnT w="0">
+                      <a:noFill/>
+                    </a:lnT>
+                    <a:lnB w="6350">
+                      <a:solidFill>
+                        <a:srgbClr val="D5DEE8"/>
+                      </a:solidFill>
+                    </a:lnB>
+                    <a:solidFill>
+                      <a:srgbClr val="EDF2F8"/>
+                    </a:solidFill>
+                  </a:tcPr>
+                </a:tc>
+                <a:tc>
+                  <a:txBody>
+                    <a:bodyPr/>
+                    <a:lstStyle/>
+                    <a:p>
+                      <a:r>
+                        <a:rPr lang="en-US" sz="1000" b="0" dirty="0">
+                          <a:solidFill>
+                            <a:srgbClr val="3D5166"/>
+                          </a:solidFill>
+                          <a:latin typeface="Arial"/>
+                        </a:rPr>
+                        <a:t>Matches</a:t>
+                      </a:r>
+                    </a:p>
+                  </a:txBody>
+                  <a:tcPr marL="91440" marR="91440" marT="45720" marB="45720" anchor="ctr">
+                    <a:lnL w="0">
+                      <a:noFill/>
+                    </a:lnL>
+                    <a:lnR w="0">
+                      <a:noFill/>
+                    </a:lnR>
+                    <a:lnT w="0">
+                      <a:noFill/>
+                    </a:lnT>
+                    <a:lnB w="6350">
+                      <a:solidFill>
+                        <a:srgbClr val="D5DEE8"/>
+                      </a:solidFill>
+                    </a:lnB>
+                    <a:solidFill>
+                      <a:srgbClr val="EDF2F8"/>
+                    </a:solidFill>
+                  </a:tcPr>
+                </a:tc>
+              </a:tr>
+              <a:tr h="347472">
+                <a:tc>
+                  <a:txBody>
+                    <a:bodyPr/>
+                    <a:lstStyle/>
+                    <a:p>
+                      <a:r>
+                        <a:rPr lang="en-US" sz="1000" b="0" dirty="0">
+                          <a:solidFill>
+                            <a:srgbClr val="0E2A47"/>
+                          </a:solidFill>
+                          <a:latin typeface="Arial"/>
+                        </a:rPr>
+                        <a:t>New-product offer: orders, discount</a:t>
+                      </a:r>
+                    </a:p>
+                  </a:txBody>
+                  <a:tcPr marL="91440" marR="91440" marT="45720" marB="45720" anchor="ctr">
+                    <a:lnL w="0">
+                      <a:noFill/>
+                    </a:lnL>
+                    <a:lnR w="0">
+                      <a:noFill/>
+                    </a:lnR>
+                    <a:lnT w="0">
+                      <a:noFill/>
+                    </a:lnT>
+                    <a:lnB w="6350">
+                      <a:solidFill>
+                        <a:srgbClr val="D5DEE8"/>
+                      </a:solidFill>
+                    </a:lnB>
+                    <a:solidFill>
+                      <a:srgbClr val="FFFFFF"/>
+                    </a:solidFill>
+                  </a:tcPr>
+                </a:tc>
+                <a:tc>
+                  <a:txBody>
+                    <a:bodyPr/>
+                    <a:lstStyle/>
+                    <a:p>
+                      <a:r>
+                        <a:rPr lang="en-US" sz="1000" b="0" dirty="0">
+                          <a:solidFill>
+                            <a:srgbClr val="3D5166"/>
+                          </a:solidFill>
+                          <a:latin typeface="Arial"/>
+                        </a:rPr>
+                        <a:t>33, 17%</a:t>
+                      </a:r>
+                    </a:p>
+                  </a:txBody>
+                  <a:tcPr marL="91440" marR="91440" marT="45720" marB="45720" anchor="ctr">
+                    <a:lnL w="0">
+                      <a:noFill/>
+                    </a:lnL>
+                    <a:lnR w="0">
+                      <a:noFill/>
+                    </a:lnR>
+                    <a:lnT w="0">
+                      <a:noFill/>
+                    </a:lnT>
+                    <a:lnB w="6350">
+                      <a:solidFill>
+                        <a:srgbClr val="D5DEE8"/>
+                      </a:solidFill>
+                    </a:lnB>
+                    <a:solidFill>
+                      <a:srgbClr val="FFFFFF"/>
+                    </a:solidFill>
+                  </a:tcPr>
+                </a:tc>
+                <a:tc>
+                  <a:txBody>
+                    <a:bodyPr/>
+                    <a:lstStyle/>
+                    <a:p>
+                      <a:r>
+                        <a:rPr lang="en-US" sz="1000" b="0" dirty="0">
+                          <a:solidFill>
+                            <a:srgbClr val="3D5166"/>
+                          </a:solidFill>
+                          <a:latin typeface="Arial"/>
+                        </a:rPr>
+                        <a:t>33, 17.0%</a:t>
+                      </a:r>
+                    </a:p>
+                  </a:txBody>
+                  <a:tcPr marL="91440" marR="91440" marT="45720" marB="45720" anchor="ctr">
+                    <a:lnL w="0">
+                      <a:noFill/>
+                    </a:lnL>
+                    <a:lnR w="0">
+                      <a:noFill/>
+                    </a:lnR>
+                    <a:lnT w="0">
+                      <a:noFill/>
+                    </a:lnT>
+                    <a:lnB w="6350">
+                      <a:solidFill>
+                        <a:srgbClr val="D5DEE8"/>
+                      </a:solidFill>
+                    </a:lnB>
+                    <a:solidFill>
+                      <a:srgbClr val="FFFFFF"/>
+                    </a:solidFill>
+                  </a:tcPr>
+                </a:tc>
+                <a:tc>
+                  <a:txBody>
+                    <a:bodyPr/>
+                    <a:lstStyle/>
+                    <a:p>
+                      <a:r>
+                        <a:rPr lang="en-US" sz="1000" b="0" dirty="0">
+                          <a:solidFill>
+                            <a:srgbClr val="3D5166"/>
+                          </a:solidFill>
+                          <a:latin typeface="Arial"/>
+                        </a:rPr>
+                        <a:t>Matches</a:t>
+                      </a:r>
+                    </a:p>
+                  </a:txBody>
+                  <a:tcPr marL="91440" marR="91440" marT="45720" marB="45720" anchor="ctr">
+                    <a:lnL w="0">
+                      <a:noFill/>
+                    </a:lnL>
+                    <a:lnR w="0">
+                      <a:noFill/>
+                    </a:lnR>
+                    <a:lnT w="0">
+                      <a:noFill/>
+                    </a:lnT>
+                    <a:lnB w="6350">
+                      <a:solidFill>
+                        <a:srgbClr val="D5DEE8"/>
+                      </a:solidFill>
+                    </a:lnB>
+                    <a:solidFill>
+                      <a:srgbClr val="FFFFFF"/>
+                    </a:solidFill>
+                  </a:tcPr>
+                </a:tc>
+              </a:tr>
+              <a:tr h="347472">
+                <a:tc>
+                  <a:txBody>
+                    <a:bodyPr/>
+                    <a:lstStyle/>
+                    <a:p>
+                      <a:r>
+                        <a:rPr lang="en-US" sz="1000" b="0" dirty="0">
+                          <a:solidFill>
+                            <a:srgbClr val="0E2A47"/>
+                          </a:solidFill>
+                          <a:latin typeface="Arial"/>
+                        </a:rPr>
+                        <a:t>New-product offer: covers its cost?</a:t>
+                      </a:r>
+                    </a:p>
+                  </a:txBody>
+                  <a:tcPr marL="91440" marR="91440" marT="45720" marB="45720" anchor="ctr">
+                    <a:lnL w="0">
+                      <a:noFill/>
+                    </a:lnL>
+                    <a:lnR w="0">
+                      <a:noFill/>
+                    </a:lnR>
+                    <a:lnT w="0">
+                      <a:noFill/>
+                    </a:lnT>
+                    <a:lnB w="6350">
+                      <a:solidFill>
+                        <a:srgbClr val="D5DEE8"/>
+                      </a:solidFill>
+                    </a:lnB>
+                    <a:solidFill>
+                      <a:srgbClr val="EDF2F8"/>
+                    </a:solidFill>
+                  </a:tcPr>
+                </a:tc>
+                <a:tc>
+                  <a:txBody>
+                    <a:bodyPr/>
+                    <a:lstStyle/>
+                    <a:p>
+                      <a:r>
+                        <a:rPr lang="en-US" sz="1000" b="0" dirty="0">
+                          <a:solidFill>
+                            <a:srgbClr val="3D5166"/>
+                          </a:solidFill>
+                          <a:latin typeface="Arial"/>
+                        </a:rPr>
+                        <a:t>No</a:t>
+                      </a:r>
+                    </a:p>
+                  </a:txBody>
+                  <a:tcPr marL="91440" marR="91440" marT="45720" marB="45720" anchor="ctr">
+                    <a:lnL w="0">
+                      <a:noFill/>
+                    </a:lnL>
+                    <a:lnR w="0">
+                      <a:noFill/>
+                    </a:lnR>
+                    <a:lnT w="0">
+                      <a:noFill/>
+                    </a:lnT>
+                    <a:lnB w="6350">
+                      <a:solidFill>
+                        <a:srgbClr val="D5DEE8"/>
+                      </a:solidFill>
+                    </a:lnB>
+                    <a:solidFill>
+                      <a:srgbClr val="EDF2F8"/>
+                    </a:solidFill>
+                  </a:tcPr>
+                </a:tc>
+                <a:tc>
+                  <a:txBody>
+                    <a:bodyPr/>
+                    <a:lstStyle/>
+                    <a:p>
+                      <a:r>
+                        <a:rPr lang="en-US" sz="1000" b="0" dirty="0">
+                          <a:solidFill>
+                            <a:srgbClr val="3D5166"/>
+                          </a:solidFill>
+                          <a:latin typeface="Arial"/>
+                        </a:rPr>
+                        <a:t>Yes: 23.5% margin</a:t>
+                      </a:r>
+                    </a:p>
+                  </a:txBody>
+                  <a:tcPr marL="91440" marR="91440" marT="45720" marB="45720" anchor="ctr">
+                    <a:lnL w="0">
+                      <a:noFill/>
+                    </a:lnL>
+                    <a:lnR w="0">
+                      <a:noFill/>
+                    </a:lnR>
+                    <a:lnT w="0">
+                      <a:noFill/>
+                    </a:lnT>
+                    <a:lnB w="6350">
+                      <a:solidFill>
+                        <a:srgbClr val="D5DEE8"/>
+                      </a:solidFill>
+                    </a:lnB>
+                    <a:solidFill>
+                      <a:srgbClr val="EDF2F8"/>
+                    </a:solidFill>
+                  </a:tcPr>
+                </a:tc>
+                <a:tc>
+                  <a:txBody>
+                    <a:bodyPr/>
+                    <a:lstStyle/>
+                    <a:p>
+                      <a:r>
+                        <a:rPr lang="en-US" sz="1000" b="1" dirty="0">
+                          <a:solidFill>
+                            <a:srgbClr val="2E75B6"/>
+                          </a:solidFill>
+                          <a:latin typeface="Arial"/>
+                        </a:rPr>
+                        <a:t>Revised (p.11)</a:t>
+                      </a:r>
+                    </a:p>
+                  </a:txBody>
+                  <a:tcPr marL="91440" marR="91440" marT="45720" marB="45720" anchor="ctr">
+                    <a:lnL w="0">
+                      <a:noFill/>
+                    </a:lnL>
+                    <a:lnR w="0">
+                      <a:noFill/>
+                    </a:lnR>
+                    <a:lnT w="0">
+                      <a:noFill/>
+                    </a:lnT>
+                    <a:lnB w="6350">
+                      <a:solidFill>
+                        <a:srgbClr val="D5DEE8"/>
+                      </a:solidFill>
+                    </a:lnB>
+                    <a:solidFill>
+                      <a:srgbClr val="EDF2F8"/>
+                    </a:solidFill>
+                  </a:tcPr>
+                </a:tc>
+              </a:tr>
+              <a:tr h="347472">
+                <a:tc>
+                  <a:txBody>
+                    <a:bodyPr/>
+                    <a:lstStyle/>
+                    <a:p>
+                      <a:r>
+                        <a:rPr lang="en-US" sz="1000" b="0" dirty="0">
+                          <a:solidFill>
+                            <a:srgbClr val="0E2A47"/>
+                          </a:solidFill>
+                          <a:latin typeface="Arial"/>
+                        </a:rPr>
+                        <a:t>Orders at the shallowest tier</a:t>
+                      </a:r>
+                    </a:p>
+                  </a:txBody>
+                  <a:tcPr marL="91440" marR="91440" marT="45720" marB="45720" anchor="ctr">
+                    <a:lnL w="0">
+                      <a:noFill/>
+                    </a:lnL>
+                    <a:lnR w="0">
+                      <a:noFill/>
+                    </a:lnR>
+                    <a:lnT w="0">
+                      <a:noFill/>
+                    </a:lnT>
+                    <a:lnB w="6350">
+                      <a:solidFill>
+                        <a:srgbClr val="D5DEE8"/>
+                      </a:solidFill>
+                    </a:lnB>
+                    <a:solidFill>
+                      <a:srgbClr val="FFFFFF"/>
+                    </a:solidFill>
+                  </a:tcPr>
+                </a:tc>
+                <a:tc>
+                  <a:txBody>
+                    <a:bodyPr/>
+                    <a:lstStyle/>
+                    <a:p>
+                      <a:r>
+                        <a:rPr lang="en-US" sz="1000" b="0" dirty="0">
+                          <a:solidFill>
+                            <a:srgbClr val="3D5166"/>
+                          </a:solidFill>
+                          <a:latin typeface="Arial"/>
+                        </a:rPr>
+                        <a:t>91%, 11-14 units</a:t>
+                      </a:r>
+                    </a:p>
+                  </a:txBody>
+                  <a:tcPr marL="91440" marR="91440" marT="45720" marB="45720" anchor="ctr">
+                    <a:lnL w="0">
+                      <a:noFill/>
+                    </a:lnL>
+                    <a:lnR w="0">
+                      <a:noFill/>
+                    </a:lnR>
+                    <a:lnT w="0">
+                      <a:noFill/>
+                    </a:lnT>
+                    <a:lnB w="6350">
+                      <a:solidFill>
+                        <a:srgbClr val="D5DEE8"/>
+                      </a:solidFill>
+                    </a:lnB>
+                    <a:solidFill>
+                      <a:srgbClr val="FFFFFF"/>
+                    </a:solidFill>
+                  </a:tcPr>
+                </a:tc>
+                <a:tc>
+                  <a:txBody>
+                    <a:bodyPr/>
+                    <a:lstStyle/>
+                    <a:p>
+                      <a:r>
+                        <a:rPr lang="en-US" sz="1000" b="0" dirty="0">
+                          <a:solidFill>
+                            <a:srgbClr val="3D5166"/>
+                          </a:solidFill>
+                          <a:latin typeface="Arial"/>
+                        </a:rPr>
+                        <a:t>97.8%, exactly 5 units</a:t>
+                      </a:r>
+                    </a:p>
+                  </a:txBody>
+                  <a:tcPr marL="91440" marR="91440" marT="45720" marB="45720" anchor="ctr">
+                    <a:lnL w="0">
+                      <a:noFill/>
+                    </a:lnL>
+                    <a:lnR w="0">
+                      <a:noFill/>
+                    </a:lnR>
+                    <a:lnT w="0">
+                      <a:noFill/>
+                    </a:lnT>
+                    <a:lnB w="6350">
+                      <a:solidFill>
+                        <a:srgbClr val="D5DEE8"/>
+                      </a:solidFill>
+                    </a:lnB>
+                    <a:solidFill>
+                      <a:srgbClr val="FFFFFF"/>
+                    </a:solidFill>
+                  </a:tcPr>
+                </a:tc>
+                <a:tc>
+                  <a:txBody>
+                    <a:bodyPr/>
+                    <a:lstStyle/>
+                    <a:p>
+                      <a:r>
+                        <a:rPr lang="en-US" sz="1000" b="1" dirty="0">
+                          <a:solidFill>
+                            <a:srgbClr val="2E75B6"/>
+                          </a:solidFill>
+                          <a:latin typeface="Arial"/>
+                        </a:rPr>
+                        <a:t>Revised (p.11)</a:t>
+                      </a:r>
+                    </a:p>
+                  </a:txBody>
+                  <a:tcPr marL="91440" marR="91440" marT="45720" marB="45720" anchor="ctr">
+                    <a:lnL w="0">
+                      <a:noFill/>
+                    </a:lnL>
+                    <a:lnR w="0">
+                      <a:noFill/>
+                    </a:lnR>
+                    <a:lnT w="0">
+                      <a:noFill/>
+                    </a:lnT>
+                    <a:lnB w="6350">
+                      <a:solidFill>
+                        <a:srgbClr val="D5DEE8"/>
+                      </a:solidFill>
+                    </a:lnB>
+                    <a:solidFill>
+                      <a:srgbClr val="FFFFFF"/>
+                    </a:solidFill>
+                  </a:tcPr>
+                </a:tc>
+              </a:tr>
+              <a:tr h="347472">
+                <a:tc>
+                  <a:txBody>
+                    <a:bodyPr/>
+                    <a:lstStyle/>
+                    <a:p>
+                      <a:r>
+                        <a:rPr lang="en-US" sz="1000" b="0" dirty="0">
+                          <a:solidFill>
+                            <a:srgbClr val="0E2A47"/>
+                          </a:solidFill>
+                          <a:latin typeface="Arial"/>
+                        </a:rPr>
+                        <a:t>Promotions outside the data window</a:t>
+                      </a:r>
+                    </a:p>
+                  </a:txBody>
+                  <a:tcPr marL="91440" marR="91440" marT="45720" marB="45720" anchor="ctr">
+                    <a:lnL w="0">
+                      <a:noFill/>
+                    </a:lnL>
+                    <a:lnR w="0">
+                      <a:noFill/>
+                    </a:lnR>
+                    <a:lnT w="0">
+                      <a:noFill/>
+                    </a:lnT>
+                    <a:lnB w="6350">
+                      <a:solidFill>
+                        <a:srgbClr val="D5DEE8"/>
+                      </a:solidFill>
+                    </a:lnB>
+                    <a:solidFill>
+                      <a:srgbClr val="EDF2F8"/>
+                    </a:solidFill>
+                  </a:tcPr>
+                </a:tc>
+                <a:tc>
+                  <a:txBody>
+                    <a:bodyPr/>
+                    <a:lstStyle/>
+                    <a:p>
+                      <a:r>
+                        <a:rPr lang="en-US" sz="1000" b="0" dirty="0">
+                          <a:solidFill>
+                            <a:srgbClr val="3D5166"/>
+                          </a:solidFill>
+                          <a:latin typeface="Arial"/>
+                        </a:rPr>
+                        <a:t>9 of 16</a:t>
+                      </a:r>
+                    </a:p>
+                  </a:txBody>
+                  <a:tcPr marL="91440" marR="91440" marT="45720" marB="45720" anchor="ctr">
+                    <a:lnL w="0">
+                      <a:noFill/>
+                    </a:lnL>
+                    <a:lnR w="0">
+                      <a:noFill/>
+                    </a:lnR>
+                    <a:lnT w="0">
+                      <a:noFill/>
+                    </a:lnT>
+                    <a:lnB w="6350">
+                      <a:solidFill>
+                        <a:srgbClr val="D5DEE8"/>
+                      </a:solidFill>
+                    </a:lnB>
+                    <a:solidFill>
+                      <a:srgbClr val="EDF2F8"/>
+                    </a:solidFill>
+                  </a:tcPr>
+                </a:tc>
+                <a:tc>
+                  <a:txBody>
+                    <a:bodyPr/>
+                    <a:lstStyle/>
+                    <a:p>
+                      <a:r>
+                        <a:rPr lang="en-US" sz="1000" b="0" dirty="0">
+                          <a:solidFill>
+                            <a:srgbClr val="3D5166"/>
+                          </a:solidFill>
+                          <a:latin typeface="Arial"/>
+                        </a:rPr>
+                        <a:t>16 of 16; 8 never used</a:t>
+                      </a:r>
+                    </a:p>
+                  </a:txBody>
+                  <a:tcPr marL="91440" marR="91440" marT="45720" marB="45720" anchor="ctr">
+                    <a:lnL w="0">
+                      <a:noFill/>
+                    </a:lnL>
+                    <a:lnR w="0">
+                      <a:noFill/>
+                    </a:lnR>
+                    <a:lnT w="0">
+                      <a:noFill/>
+                    </a:lnT>
+                    <a:lnB w="6350">
+                      <a:solidFill>
+                        <a:srgbClr val="D5DEE8"/>
+                      </a:solidFill>
+                    </a:lnB>
+                    <a:solidFill>
+                      <a:srgbClr val="EDF2F8"/>
+                    </a:solidFill>
+                  </a:tcPr>
+                </a:tc>
+                <a:tc>
+                  <a:txBody>
+                    <a:bodyPr/>
+                    <a:lstStyle/>
+                    <a:p>
+                      <a:r>
+                        <a:rPr lang="en-US" sz="1000" b="1" dirty="0">
+                          <a:solidFill>
+                            <a:srgbClr val="2E75B6"/>
+                          </a:solidFill>
+                          <a:latin typeface="Arial"/>
+                        </a:rPr>
+                        <a:t>Revised (p.12)</a:t>
+                      </a:r>
+                    </a:p>
+                  </a:txBody>
+                  <a:tcPr marL="91440" marR="91440" marT="45720" marB="45720" anchor="ctr">
+                    <a:lnL w="0">
+                      <a:noFill/>
+                    </a:lnL>
+                    <a:lnR w="0">
+                      <a:noFill/>
+                    </a:lnR>
+                    <a:lnT w="0">
+                      <a:noFill/>
+                    </a:lnT>
+                    <a:lnB w="6350">
+                      <a:solidFill>
+                        <a:srgbClr val="D5DEE8"/>
+                      </a:solidFill>
+                    </a:lnB>
+                    <a:solidFill>
+                      <a:srgbClr val="EDF2F8"/>
+                    </a:solidFill>
+                  </a:tcPr>
+                </a:tc>
+              </a:tr>
+              <a:tr h="347472">
+                <a:tc>
+                  <a:txBody>
+                    <a:bodyPr/>
+                    <a:lstStyle/>
+                    <a:p>
+                      <a:r>
+                        <a:rPr lang="en-US" sz="1000" b="0" dirty="0">
+                          <a:solidFill>
+                            <a:srgbClr val="0E2A47"/>
+                          </a:solidFill>
+                          <a:latin typeface="Arial"/>
+                        </a:rPr>
+                        <a:t>Mislabeled "Occupation" chart</a:t>
+                      </a:r>
+                    </a:p>
+                  </a:txBody>
+                  <a:tcPr marL="91440" marR="91440" marT="45720" marB="45720" anchor="ctr">
+                    <a:lnL w="0">
+                      <a:noFill/>
+                    </a:lnL>
+                    <a:lnR w="0">
+                      <a:noFill/>
+                    </a:lnR>
+                    <a:lnT w="0">
+                      <a:noFill/>
+                    </a:lnT>
+                    <a:lnB w="6350">
+                      <a:solidFill>
+                        <a:srgbClr val="D5DEE8"/>
+                      </a:solidFill>
+                    </a:lnB>
+                    <a:solidFill>
+                      <a:srgbClr val="FFFFFF"/>
+                    </a:solidFill>
+                  </a:tcPr>
+                </a:tc>
+                <a:tc>
+                  <a:txBody>
+                    <a:bodyPr/>
+                    <a:lstStyle/>
+                    <a:p>
+                      <a:r>
+                        <a:rPr lang="en-US" sz="1000" b="0" dirty="0">
+                          <a:solidFill>
+                            <a:srgbClr val="3D5166"/>
+                          </a:solidFill>
+                          <a:latin typeface="Arial"/>
+                        </a:rPr>
+                        <a:t>Left one</a:t>
+                      </a:r>
+                    </a:p>
+                  </a:txBody>
+                  <a:tcPr marL="91440" marR="91440" marT="45720" marB="45720" anchor="ctr">
+                    <a:lnL w="0">
+                      <a:noFill/>
+                    </a:lnL>
+                    <a:lnR w="0">
+                      <a:noFill/>
+                    </a:lnR>
+                    <a:lnT w="0">
+                      <a:noFill/>
+                    </a:lnT>
+                    <a:lnB w="6350">
+                      <a:solidFill>
+                        <a:srgbClr val="D5DEE8"/>
+                      </a:solidFill>
+                    </a:lnB>
+                    <a:solidFill>
+                      <a:srgbClr val="FFFFFF"/>
+                    </a:solidFill>
+                  </a:tcPr>
+                </a:tc>
+                <a:tc>
+                  <a:txBody>
+                    <a:bodyPr/>
+                    <a:lstStyle/>
+                    <a:p>
+                      <a:r>
+                        <a:rPr lang="en-US" sz="1000" b="0" dirty="0">
+                          <a:solidFill>
+                            <a:srgbClr val="3D5166"/>
+                          </a:solidFill>
+                          <a:latin typeface="Arial"/>
+                        </a:rPr>
+                        <a:t>Top-right one</a:t>
+                      </a:r>
+                    </a:p>
+                  </a:txBody>
+                  <a:tcPr marL="91440" marR="91440" marT="45720" marB="45720" anchor="ctr">
+                    <a:lnL w="0">
+                      <a:noFill/>
+                    </a:lnL>
+                    <a:lnR w="0">
+                      <a:noFill/>
+                    </a:lnR>
+                    <a:lnT w="0">
+                      <a:noFill/>
+                    </a:lnT>
+                    <a:lnB w="6350">
+                      <a:solidFill>
+                        <a:srgbClr val="D5DEE8"/>
+                      </a:solidFill>
+                    </a:lnB>
+                    <a:solidFill>
+                      <a:srgbClr val="FFFFFF"/>
+                    </a:solidFill>
+                  </a:tcPr>
+                </a:tc>
+                <a:tc>
+                  <a:txBody>
+                    <a:bodyPr/>
+                    <a:lstStyle/>
+                    <a:p>
+                      <a:r>
+                        <a:rPr lang="en-US" sz="1000" b="1" dirty="0">
+                          <a:solidFill>
+                            <a:srgbClr val="2E75B6"/>
+                          </a:solidFill>
+                          <a:latin typeface="Arial"/>
+                        </a:rPr>
+                        <a:t>Revised (p.5, p.12)</a:t>
+                      </a:r>
+                    </a:p>
+                  </a:txBody>
+                  <a:tcPr marL="91440" marR="91440" marT="45720" marB="45720" anchor="ctr">
+                    <a:lnL w="0">
+                      <a:noFill/>
+                    </a:lnL>
+                    <a:lnR w="0">
+                      <a:noFill/>
+                    </a:lnR>
+                    <a:lnT w="0">
+                      <a:noFill/>
+                    </a:lnT>
+                    <a:lnB w="6350">
+                      <a:solidFill>
+                        <a:srgbClr val="D5DEE8"/>
+                      </a:solidFill>
+                    </a:lnB>
+                    <a:solidFill>
+                      <a:srgbClr val="FFFFFF"/>
+                    </a:solidFill>
+                  </a:tcPr>
+                </a:tc>
+              </a:tr>
+            </a:tbl>
+          </a:graphicData>
+        </a:graphic>
+      </p:graphicFrame>
+      <p:sp>
+        <p:nvSpPr>
+          <p:cNvPr id="8" name="Method Note"/>
+          <p:cNvSpPr txBox="1"/>
+          <p:nvPr/>
+        </p:nvSpPr>
+        <p:spPr>
+          <a:xfrm>
+            <a:off x="548640" y="6089904"/>
+            <a:ext cx="10972800" cy="320040"/>
+          </a:xfrm>
+          <a:prstGeom prst="rect">
+            <a:avLst/>
+          </a:prstGeom>
+          <a:noFill/>
+        </p:spPr>
+        <p:txBody>
+          <a:bodyPr wrap="square" lIns="0" rIns="0" anchor="t"/>
+          <a:lstStyle/>
+          <a:p>
+            <a:pPr algn="l"/>
+            <a:r>
+              <a:rPr lang="en-US" sz="900" b="0" i="1" dirty="0">
+                <a:solidFill>
+                  <a:srgbClr val="3D5166"/>
+                </a:solidFill>
+                <a:latin typeface="Arial"/>
+              </a:rPr>
+              <a:t>Method: the data model in RFM_Updated_2.pbix was extracted with pbixray and recomputed in pandas. Margin = sales_amount - unit_cost x order_quantity; it excludes any campaign costs not in the data.</a:t>
+            </a:r>
+          </a:p>
+        </p:txBody>
+      </p:sp>
+    </p:spTree>
+    <p:extLst>
+      <p:ext uri="{BB962C8B-B14F-4D97-AF65-F5344CB8AC3E}">
+        <p14:creationId xmlns:p14="http://schemas.microsoft.com/office/powerpoint/2010/main" val="291678280"/>
       </p:ext>
     </p:extLst>
   </p:cSld>
@@ -7550,7 +9745,7 @@
                 </a:solidFill>
                 <a:latin typeface="Consolas"/>
               </a:rPr>
-              <a:t>02 / 13</a:t>
+              <a:t>02 / 14</a:t>
             </a:r>
           </a:p>
         </p:txBody>
@@ -8413,7 +10608,7 @@
                 </a:solidFill>
                 <a:latin typeface="Consolas"/>
               </a:rPr>
-              <a:t>03 / 13</a:t>
+              <a:t>03 / 14</a:t>
             </a:r>
           </a:p>
         </p:txBody>
@@ -9160,7 +11355,7 @@
                 </a:solidFill>
                 <a:latin typeface="Consolas"/>
               </a:rPr>
-              <a:t>04 / 13</a:t>
+              <a:t>04 / 14</a:t>
             </a:r>
           </a:p>
         </p:txBody>
@@ -9907,7 +12102,7 @@
                 </a:solidFill>
                 <a:latin typeface="Consolas"/>
               </a:rPr>
-              <a:t>05 / 13</a:t>
+              <a:t>05 / 14</a:t>
             </a:r>
           </a:p>
         </p:txBody>
@@ -10403,7 +12598,7 @@
                 </a:solidFill>
                 <a:latin typeface="Arial"/>
               </a:rPr>
-              <a:t>The left "Occupation Distribution" matrix is mislabeled: it's actually</a:t>
+              <a:t>The top-right "Occupation Distribution" chart is mislabeled: it's actually</a:t>
             </a:r>
             <a:r>
               <a:rPr sz="1100" b="0" i="0">
@@ -10654,7 +12849,7 @@
                 </a:solidFill>
                 <a:latin typeface="Consolas"/>
               </a:rPr>
-              <a:t>06 / 13</a:t>
+              <a:t>06 / 14</a:t>
             </a:r>
           </a:p>
         </p:txBody>
@@ -11159,7 +13354,7 @@
                 </a:solidFill>
                 <a:latin typeface="Arial"/>
               </a:rPr>
-              <a:t>are both undercounts. See p.12.</a:t>
+              <a:t>are both undercounts (true figures 4,818 / 4.05bn). See p.12.</a:t>
             </a:r>
           </a:p>
         </p:txBody>
@@ -11471,7 +13666,7 @@
                 </a:solidFill>
                 <a:latin typeface="Consolas"/>
               </a:rPr>
-              <a:t>07 / 13</a:t>
+              <a:t>07 / 14</a:t>
             </a:r>
           </a:p>
         </p:txBody>
@@ -11620,7 +13815,7 @@
                 </a:solidFill>
                 <a:latin typeface="Consolas"/>
               </a:rPr>
-              <a:t>08 / 13</a:t>
+              <a:t>08 / 14</a:t>
             </a:r>
           </a:p>
         </p:txBody>
@@ -13856,7 +16051,7 @@
                 </a:solidFill>
                 <a:latin typeface="Consolas"/>
               </a:rPr>
-              <a:t>09 / 13</a:t>
+              <a:t>09 / 14</a:t>
             </a:r>
           </a:p>
         </p:txBody>

</xml_diff>